<commit_message>
Cập nhật tình huống SGK và thêm đồng hồ suy nghĩ 30 giây
Co-authored-by: arena-agent <297053741+arena-agent@users.noreply.github.com>
</commit_message>
<xml_diff>
--- a/Phát triển mối quan hệ hòa đồng, hợp tác - HĐTN lớp 7 (học sinh thuyết trình).pptx
+++ b/Phát triển mối quan hệ hòa đồng, hợp tác - HĐTN lớp 7 (học sinh thuyết trình).pptx
@@ -7226,7 +7226,7 @@
                 </a:solidFill>
                 <a:latin typeface="Liberation Sans"/>
               </a:rPr>
-              <a:t>Bạn ốm trước buổi biểu diễn</a:t>
+              <a:t>Thành viên ốm trước ngày biểu diễn</a:t>
             </a:r>
           </a:p>
         </p:txBody>
@@ -7372,7 +7372,7 @@
                 </a:solidFill>
                 <a:latin typeface="Liberation Sans"/>
               </a:rPr>
-              <a:t>Bạn mới chuyển đến nhút nhát</a:t>
+              <a:t>Minh mới chuyển đến lớp 7B</a:t>
             </a:r>
           </a:p>
         </p:txBody>
@@ -8546,6 +8546,117 @@
         </p:nvSpPr>
         <p:spPr>
           <a:xfrm>
+            <a:off x="10436047" y="393192"/>
+            <a:ext cx="1152144" cy="530352"/>
+          </a:xfrm>
+          <a:prstGeom prst="roundRect">
+            <a:avLst>
+              <a:gd name="adj" fmla="val 18000"/>
+            </a:avLst>
+          </a:prstGeom>
+          <a:effectLst/>
+          <a:solidFill>
+            <a:srgbClr val="FFFFFF">
+              <a:alpha val="92000"/>
+            </a:srgbClr>
+          </a:solidFill>
+          <a:ln w="10160" cap="flat" cmpd="sng" algn="ctr">
+            <a:solidFill>
+              <a:srgbClr val="0A66E0">
+                <a:alpha val="35000"/>
+              </a:srgbClr>
+            </a:solidFill>
+          </a:ln>
+        </p:spPr>
+        <p:style>
+          <a:lnRef idx="1">
+            <a:schemeClr val="accent1"/>
+          </a:lnRef>
+          <a:fillRef idx="3">
+            <a:schemeClr val="accent1"/>
+          </a:fillRef>
+          <a:effectRef idx="2">
+            <a:schemeClr val="accent1"/>
+          </a:effectRef>
+          <a:fontRef idx="minor">
+            <a:schemeClr val="lt1"/>
+          </a:fontRef>
+        </p:style>
+        <p:txBody>
+          <a:bodyPr rtlCol="0" anchor="ctr"/>
+          <a:lstStyle/>
+          <a:p>
+            <a:pPr algn="ctr"/>
+          </a:p>
+        </p:txBody>
+      </p:sp>
+      <p:sp>
+        <p:nvSpPr>
+          <p:cNvPr id="25" name="TextBox 24"/>
+          <p:cNvSpPr txBox="1"/>
+          <p:nvPr/>
+        </p:nvSpPr>
+        <p:spPr>
+          <a:xfrm>
+            <a:off x="10545775" y="443484"/>
+            <a:ext cx="932688" cy="109728"/>
+          </a:xfrm>
+          <a:prstGeom prst="rect">
+            <a:avLst/>
+          </a:prstGeom>
+          <a:noFill/>
+        </p:spPr>
+        <p:txBody>
+          <a:bodyPr wrap="square" anchor="t" lIns="0" rIns="0" tIns="0" bIns="0">
+            <a:spAutoFit/>
+          </a:bodyPr>
+          <a:lstStyle/>
+          <a:p>
+            <a:pPr algn="ctr"/>
+            <a:r>
+              <a:rPr sz="620" b="1" i="0" spc="80">
+                <a:solidFill>
+                  <a:srgbClr val="8A93B4"/>
+                </a:solidFill>
+                <a:latin typeface="Liberation Sans"/>
+              </a:rPr>
+              <a:t>SUY NGHĨ</a:t>
+            </a:r>
+          </a:p>
+        </p:txBody>
+      </p:sp>
+      <p:pic>
+        <p:nvPicPr>
+          <p:cNvPr id="26" name="Picture 25" descr="suy-nghi-30s.gif"/>
+          <p:cNvPicPr>
+            <a:picLocks noChangeAspect="1"/>
+          </p:cNvPicPr>
+          <p:nvPr/>
+        </p:nvPicPr>
+        <p:blipFill>
+          <a:blip r:embed="rId3"/>
+          <a:stretch>
+            <a:fillRect/>
+          </a:stretch>
+        </p:blipFill>
+        <p:spPr>
+          <a:xfrm>
+            <a:off x="10573207" y="576072"/>
+            <a:ext cx="877824" cy="274320"/>
+          </a:xfrm>
+          <a:prstGeom prst="rect">
+            <a:avLst/>
+          </a:prstGeom>
+        </p:spPr>
+      </p:pic>
+      <p:sp>
+        <p:nvSpPr>
+          <p:cNvPr id="27" name="Rounded Rectangle 26"/>
+          <p:cNvSpPr/>
+          <p:nvPr/>
+        </p:nvSpPr>
+        <p:spPr>
+          <a:xfrm>
             <a:off x="603504" y="1572768"/>
             <a:ext cx="10984687" cy="1335024"/>
           </a:xfrm>
@@ -8592,7 +8703,7 @@
       </p:sp>
       <p:pic>
         <p:nvPicPr>
-          <p:cNvPr id="25" name="Picture 24" descr="drop-triangle-fill.png"/>
+          <p:cNvPr id="28" name="Picture 27" descr="drop-triangle-fill.png"/>
           <p:cNvPicPr>
             <a:picLocks noChangeAspect="1"/>
           </p:cNvPicPr>
@@ -8616,7 +8727,7 @@
       </p:pic>
       <p:sp>
         <p:nvSpPr>
-          <p:cNvPr id="26" name="TextBox 25"/>
+          <p:cNvPr id="29" name="TextBox 28"/>
           <p:cNvSpPr txBox="1"/>
           <p:nvPr/>
         </p:nvSpPr>
@@ -8657,14 +8768,14 @@
                 </a:solidFill>
                 <a:latin typeface="Liberation Sans"/>
               </a:rPr>
-              <a:t>Trong giờ thực hành môn Khoa học tự nhiên, các bạn cùng nhóm với Thanh đang làm thí nghiệm thì Thanh lấy bài tập Toán ra làm, không tham gia cùng nhóm.</a:t>
+              <a:t>Trong tiết thực hành môn Khoa học tự nhiên, các bạn cùng nhóm với Thanh đang làm thí nghiệm thì Thanh mang bài tập Toán ra làm.</a:t>
             </a:r>
           </a:p>
         </p:txBody>
       </p:sp>
       <p:sp>
         <p:nvSpPr>
-          <p:cNvPr id="27" name="Rounded Rectangle 26"/>
+          <p:cNvPr id="30" name="Rounded Rectangle 29"/>
           <p:cNvSpPr/>
           <p:nvPr/>
         </p:nvSpPr>
@@ -8716,7 +8827,7 @@
       </p:sp>
       <p:sp>
         <p:nvSpPr>
-          <p:cNvPr id="28" name="TextBox 27"/>
+          <p:cNvPr id="31" name="TextBox 30"/>
           <p:cNvSpPr txBox="1"/>
           <p:nvPr/>
         </p:nvSpPr>
@@ -8751,7 +8862,7 @@
       </p:sp>
       <p:sp>
         <p:nvSpPr>
-          <p:cNvPr id="29" name="Oval 28"/>
+          <p:cNvPr id="32" name="Oval 31"/>
           <p:cNvSpPr/>
           <p:nvPr/>
         </p:nvSpPr>
@@ -8816,7 +8927,7 @@
       </p:sp>
       <p:sp>
         <p:nvSpPr>
-          <p:cNvPr id="30" name="TextBox 29"/>
+          <p:cNvPr id="33" name="TextBox 32"/>
           <p:cNvSpPr txBox="1"/>
           <p:nvPr/>
         </p:nvSpPr>
@@ -8855,7 +8966,7 @@
       </p:sp>
       <p:sp>
         <p:nvSpPr>
-          <p:cNvPr id="31" name="Oval 30"/>
+          <p:cNvPr id="34" name="Oval 33"/>
           <p:cNvSpPr/>
           <p:nvPr/>
         </p:nvSpPr>
@@ -8920,7 +9031,7 @@
       </p:sp>
       <p:sp>
         <p:nvSpPr>
-          <p:cNvPr id="32" name="TextBox 31"/>
+          <p:cNvPr id="35" name="TextBox 34"/>
           <p:cNvSpPr txBox="1"/>
           <p:nvPr/>
         </p:nvSpPr>
@@ -8959,7 +9070,7 @@
       </p:sp>
       <p:sp>
         <p:nvSpPr>
-          <p:cNvPr id="33" name="Oval 32"/>
+          <p:cNvPr id="36" name="Oval 35"/>
           <p:cNvSpPr/>
           <p:nvPr/>
         </p:nvSpPr>
@@ -9024,7 +9135,7 @@
       </p:sp>
       <p:sp>
         <p:nvSpPr>
-          <p:cNvPr id="34" name="TextBox 33"/>
+          <p:cNvPr id="37" name="TextBox 36"/>
           <p:cNvSpPr txBox="1"/>
           <p:nvPr/>
         </p:nvSpPr>
@@ -9063,7 +9174,7 @@
       </p:sp>
       <p:sp>
         <p:nvSpPr>
-          <p:cNvPr id="35" name="Rounded Rectangle 34"/>
+          <p:cNvPr id="38" name="Rounded Rectangle 37"/>
           <p:cNvSpPr/>
           <p:nvPr/>
         </p:nvSpPr>
@@ -9115,14 +9226,14 @@
       </p:sp>
       <p:pic>
         <p:nvPicPr>
-          <p:cNvPr id="36" name="Picture 35" descr="bubble-pair-fill.png"/>
+          <p:cNvPr id="39" name="Picture 38" descr="bubble-pair-fill.png"/>
           <p:cNvPicPr>
             <a:picLocks noChangeAspect="1"/>
           </p:cNvPicPr>
           <p:nvPr/>
         </p:nvPicPr>
         <p:blipFill>
-          <a:blip r:embed="rId3"/>
+          <a:blip r:embed="rId4"/>
           <a:stretch>
             <a:fillRect/>
           </a:stretch>
@@ -9139,7 +9250,7 @@
       </p:pic>
       <p:sp>
         <p:nvSpPr>
-          <p:cNvPr id="37" name="TextBox 36"/>
+          <p:cNvPr id="40" name="TextBox 39"/>
           <p:cNvSpPr txBox="1"/>
           <p:nvPr/>
         </p:nvSpPr>
@@ -9194,7 +9305,7 @@
       </p:sp>
       <p:sp>
         <p:nvSpPr>
-          <p:cNvPr id="38" name="Rounded Rectangle 37"/>
+          <p:cNvPr id="41" name="Rounded Rectangle 40"/>
           <p:cNvSpPr/>
           <p:nvPr/>
         </p:nvSpPr>
@@ -9246,14 +9357,14 @@
       </p:sp>
       <p:pic>
         <p:nvPicPr>
-          <p:cNvPr id="39" name="Picture 38" descr="bolt-fill.png"/>
+          <p:cNvPr id="42" name="Picture 41" descr="bolt-fill.png"/>
           <p:cNvPicPr>
             <a:picLocks noChangeAspect="1"/>
           </p:cNvPicPr>
           <p:nvPr/>
         </p:nvPicPr>
         <p:blipFill>
-          <a:blip r:embed="rId4"/>
+          <a:blip r:embed="rId5"/>
           <a:stretch>
             <a:fillRect/>
           </a:stretch>
@@ -9270,7 +9381,7 @@
       </p:pic>
       <p:sp>
         <p:nvSpPr>
-          <p:cNvPr id="40" name="TextBox 39"/>
+          <p:cNvPr id="43" name="TextBox 42"/>
           <p:cNvSpPr txBox="1"/>
           <p:nvPr/>
         </p:nvSpPr>
@@ -10055,7 +10166,7 @@
                 </a:solidFill>
                 <a:latin typeface="Liberation Sans"/>
               </a:rPr>
-              <a:t>Tình huống 2: Bạn ốm trước buổi biểu diễn</a:t>
+              <a:t>Tình huống 2: Một thành viên bị ốm</a:t>
             </a:r>
           </a:p>
         </p:txBody>
@@ -10411,6 +10522,117 @@
         </p:nvSpPr>
         <p:spPr>
           <a:xfrm>
+            <a:off x="10436047" y="393192"/>
+            <a:ext cx="1152144" cy="530352"/>
+          </a:xfrm>
+          <a:prstGeom prst="roundRect">
+            <a:avLst>
+              <a:gd name="adj" fmla="val 18000"/>
+            </a:avLst>
+          </a:prstGeom>
+          <a:effectLst/>
+          <a:solidFill>
+            <a:srgbClr val="FFFFFF">
+              <a:alpha val="92000"/>
+            </a:srgbClr>
+          </a:solidFill>
+          <a:ln w="10160" cap="flat" cmpd="sng" algn="ctr">
+            <a:solidFill>
+              <a:srgbClr val="0A66E0">
+                <a:alpha val="35000"/>
+              </a:srgbClr>
+            </a:solidFill>
+          </a:ln>
+        </p:spPr>
+        <p:style>
+          <a:lnRef idx="1">
+            <a:schemeClr val="accent1"/>
+          </a:lnRef>
+          <a:fillRef idx="3">
+            <a:schemeClr val="accent1"/>
+          </a:fillRef>
+          <a:effectRef idx="2">
+            <a:schemeClr val="accent1"/>
+          </a:effectRef>
+          <a:fontRef idx="minor">
+            <a:schemeClr val="lt1"/>
+          </a:fontRef>
+        </p:style>
+        <p:txBody>
+          <a:bodyPr rtlCol="0" anchor="ctr"/>
+          <a:lstStyle/>
+          <a:p>
+            <a:pPr algn="ctr"/>
+          </a:p>
+        </p:txBody>
+      </p:sp>
+      <p:sp>
+        <p:nvSpPr>
+          <p:cNvPr id="25" name="TextBox 24"/>
+          <p:cNvSpPr txBox="1"/>
+          <p:nvPr/>
+        </p:nvSpPr>
+        <p:spPr>
+          <a:xfrm>
+            <a:off x="10545775" y="443484"/>
+            <a:ext cx="932688" cy="109728"/>
+          </a:xfrm>
+          <a:prstGeom prst="rect">
+            <a:avLst/>
+          </a:prstGeom>
+          <a:noFill/>
+        </p:spPr>
+        <p:txBody>
+          <a:bodyPr wrap="square" anchor="t" lIns="0" rIns="0" tIns="0" bIns="0">
+            <a:spAutoFit/>
+          </a:bodyPr>
+          <a:lstStyle/>
+          <a:p>
+            <a:pPr algn="ctr"/>
+            <a:r>
+              <a:rPr sz="620" b="1" i="0" spc="80">
+                <a:solidFill>
+                  <a:srgbClr val="8A93B4"/>
+                </a:solidFill>
+                <a:latin typeface="Liberation Sans"/>
+              </a:rPr>
+              <a:t>SUY NGHĨ</a:t>
+            </a:r>
+          </a:p>
+        </p:txBody>
+      </p:sp>
+      <p:pic>
+        <p:nvPicPr>
+          <p:cNvPr id="26" name="Picture 25" descr="suy-nghi-30s.gif"/>
+          <p:cNvPicPr>
+            <a:picLocks noChangeAspect="1"/>
+          </p:cNvPicPr>
+          <p:nvPr/>
+        </p:nvPicPr>
+        <p:blipFill>
+          <a:blip r:embed="rId3"/>
+          <a:stretch>
+            <a:fillRect/>
+          </a:stretch>
+        </p:blipFill>
+        <p:spPr>
+          <a:xfrm>
+            <a:off x="10573207" y="576072"/>
+            <a:ext cx="877824" cy="274320"/>
+          </a:xfrm>
+          <a:prstGeom prst="rect">
+            <a:avLst/>
+          </a:prstGeom>
+        </p:spPr>
+      </p:pic>
+      <p:sp>
+        <p:nvSpPr>
+          <p:cNvPr id="27" name="Rounded Rectangle 26"/>
+          <p:cNvSpPr/>
+          <p:nvPr/>
+        </p:nvSpPr>
+        <p:spPr>
+          <a:xfrm>
             <a:off x="603504" y="1572768"/>
             <a:ext cx="10984687" cy="1335024"/>
           </a:xfrm>
@@ -10457,7 +10679,7 @@
       </p:sp>
       <p:pic>
         <p:nvPicPr>
-          <p:cNvPr id="25" name="Picture 24" descr="waveform.png"/>
+          <p:cNvPr id="28" name="Picture 27" descr="waveform.png"/>
           <p:cNvPicPr>
             <a:picLocks noChangeAspect="1"/>
           </p:cNvPicPr>
@@ -10481,7 +10703,7 @@
       </p:pic>
       <p:sp>
         <p:nvSpPr>
-          <p:cNvPr id="26" name="TextBox 25"/>
+          <p:cNvPr id="29" name="TextBox 28"/>
           <p:cNvSpPr txBox="1"/>
           <p:nvPr/>
         </p:nvSpPr>
@@ -10522,14 +10744,14 @@
                 </a:solidFill>
                 <a:latin typeface="Liberation Sans"/>
               </a:rPr>
-              <a:t>Nhóm em đang tập tiết mục văn nghệ chào mừng ngày Nhà giáo Việt Nam. Chỉ còn hai ngày nữa là biểu diễn thì Mai — người hát chính — bị ốm, phải nghỉ học.</a:t>
+              <a:t>Nhóm của Hà được lớp giao nhiệm vụ chuẩn bị một tiểu phẩm để biểu diễn trong tiết Sinh hoạt dưới cờ. Tuy nhiên, ngay trước ngày biểu diễn thì một thành viên bị ốm.</a:t>
             </a:r>
           </a:p>
         </p:txBody>
       </p:sp>
       <p:sp>
         <p:nvSpPr>
-          <p:cNvPr id="27" name="Rounded Rectangle 26"/>
+          <p:cNvPr id="30" name="Rounded Rectangle 29"/>
           <p:cNvSpPr/>
           <p:nvPr/>
         </p:nvSpPr>
@@ -10581,7 +10803,7 @@
       </p:sp>
       <p:sp>
         <p:nvSpPr>
-          <p:cNvPr id="28" name="TextBox 27"/>
+          <p:cNvPr id="31" name="TextBox 30"/>
           <p:cNvSpPr txBox="1"/>
           <p:nvPr/>
         </p:nvSpPr>
@@ -10616,7 +10838,7 @@
       </p:sp>
       <p:sp>
         <p:nvSpPr>
-          <p:cNvPr id="29" name="Oval 28"/>
+          <p:cNvPr id="32" name="Oval 31"/>
           <p:cNvSpPr/>
           <p:nvPr/>
         </p:nvSpPr>
@@ -10681,7 +10903,7 @@
       </p:sp>
       <p:sp>
         <p:nvSpPr>
-          <p:cNvPr id="30" name="TextBox 29"/>
+          <p:cNvPr id="33" name="TextBox 32"/>
           <p:cNvSpPr txBox="1"/>
           <p:nvPr/>
         </p:nvSpPr>
@@ -10713,14 +10935,14 @@
                 </a:solidFill>
                 <a:latin typeface="Liberation Sans"/>
               </a:rPr>
-              <a:t>Việc đầu tiên nhóm nên làm với Mai là gì để bạn không thấy áy náy?</a:t>
+              <a:t>Việc đầu tiên nhóm nên làm với bạn bị ốm là gì để bạn không thấy áy náy?</a:t>
             </a:r>
           </a:p>
         </p:txBody>
       </p:sp>
       <p:sp>
         <p:nvSpPr>
-          <p:cNvPr id="31" name="Oval 30"/>
+          <p:cNvPr id="34" name="Oval 33"/>
           <p:cNvSpPr/>
           <p:nvPr/>
         </p:nvSpPr>
@@ -10785,7 +11007,7 @@
       </p:sp>
       <p:sp>
         <p:nvSpPr>
-          <p:cNvPr id="32" name="TextBox 31"/>
+          <p:cNvPr id="35" name="TextBox 34"/>
           <p:cNvSpPr txBox="1"/>
           <p:nvPr/>
         </p:nvSpPr>
@@ -10817,14 +11039,14 @@
                 </a:solidFill>
                 <a:latin typeface="Liberation Sans"/>
               </a:rPr>
-              <a:t>Nhóm có thể thay đổi phần biểu diễn như thế nào mà vẫn tôn trọng Mai?</a:t>
+              <a:t>Nhóm có thể thay đổi phần tiểu phẩm như thế nào mà vẫn tôn trọng bạn?</a:t>
             </a:r>
           </a:p>
         </p:txBody>
       </p:sp>
       <p:sp>
         <p:nvSpPr>
-          <p:cNvPr id="33" name="Oval 32"/>
+          <p:cNvPr id="36" name="Oval 35"/>
           <p:cNvSpPr/>
           <p:nvPr/>
         </p:nvSpPr>
@@ -10889,7 +11111,7 @@
       </p:sp>
       <p:sp>
         <p:nvSpPr>
-          <p:cNvPr id="34" name="TextBox 33"/>
+          <p:cNvPr id="37" name="TextBox 36"/>
           <p:cNvSpPr txBox="1"/>
           <p:nvPr/>
         </p:nvSpPr>
@@ -10921,14 +11143,14 @@
                 </a:solidFill>
                 <a:latin typeface="Liberation Sans"/>
               </a:rPr>
-              <a:t>Sau buổi biểu diễn, chúng ta nên làm gì để Mai vẫn cảm thấy mình thuộc về nhóm?</a:t>
+              <a:t>Sau buổi biểu diễn, chúng ta nên làm gì để bạn vẫn cảm thấy mình thuộc về nhóm?</a:t>
             </a:r>
           </a:p>
         </p:txBody>
       </p:sp>
       <p:sp>
         <p:nvSpPr>
-          <p:cNvPr id="35" name="Rounded Rectangle 34"/>
+          <p:cNvPr id="38" name="Rounded Rectangle 37"/>
           <p:cNvSpPr/>
           <p:nvPr/>
         </p:nvSpPr>
@@ -10980,14 +11202,14 @@
       </p:sp>
       <p:pic>
         <p:nvPicPr>
-          <p:cNvPr id="36" name="Picture 35" descr="bubble-pair-fill.png"/>
+          <p:cNvPr id="39" name="Picture 38" descr="bubble-pair-fill.png"/>
           <p:cNvPicPr>
             <a:picLocks noChangeAspect="1"/>
           </p:cNvPicPr>
           <p:nvPr/>
         </p:nvPicPr>
         <p:blipFill>
-          <a:blip r:embed="rId3"/>
+          <a:blip r:embed="rId4"/>
           <a:stretch>
             <a:fillRect/>
           </a:stretch>
@@ -11004,7 +11226,7 @@
       </p:pic>
       <p:sp>
         <p:nvSpPr>
-          <p:cNvPr id="37" name="TextBox 36"/>
+          <p:cNvPr id="40" name="TextBox 39"/>
           <p:cNvSpPr txBox="1"/>
           <p:nvPr/>
         </p:nvSpPr>
@@ -11059,7 +11281,7 @@
       </p:sp>
       <p:sp>
         <p:nvSpPr>
-          <p:cNvPr id="38" name="Rounded Rectangle 37"/>
+          <p:cNvPr id="41" name="Rounded Rectangle 40"/>
           <p:cNvSpPr/>
           <p:nvPr/>
         </p:nvSpPr>
@@ -11111,14 +11333,14 @@
       </p:sp>
       <p:pic>
         <p:nvPicPr>
-          <p:cNvPr id="39" name="Picture 38" descr="bolt-fill.png"/>
+          <p:cNvPr id="42" name="Picture 41" descr="bolt-fill.png"/>
           <p:cNvPicPr>
             <a:picLocks noChangeAspect="1"/>
           </p:cNvPicPr>
           <p:nvPr/>
         </p:nvPicPr>
         <p:blipFill>
-          <a:blip r:embed="rId4"/>
+          <a:blip r:embed="rId5"/>
           <a:stretch>
             <a:fillRect/>
           </a:stretch>
@@ -11135,7 +11357,7 @@
       </p:pic>
       <p:sp>
         <p:nvSpPr>
-          <p:cNvPr id="40" name="TextBox 39"/>
+          <p:cNvPr id="43" name="TextBox 42"/>
           <p:cNvSpPr txBox="1"/>
           <p:nvPr/>
         </p:nvSpPr>
@@ -11186,7 +11408,7 @@
                 </a:solidFill>
                 <a:latin typeface="Liberation Sans"/>
               </a:rPr>
-              <a:t>Quan tâm sức khỏe của bạn, cùng linh hoạt điều chỉnh và luôn giữ Mai trong nhóm.</a:t>
+              <a:t>Quan tâm sức khỏe của bạn, cùng linh hoạt điều chỉnh và luôn giữ bạn trong nhóm.</a:t>
             </a:r>
           </a:p>
           <a:p>
@@ -11920,7 +12142,7 @@
                 </a:solidFill>
                 <a:latin typeface="Liberation Sans"/>
               </a:rPr>
-              <a:t>Tình huống 3: Bạn mới chuyển đến lớp</a:t>
+              <a:t>Tình huống 3: Minh mới chuyển đến lớp 7B</a:t>
             </a:r>
           </a:p>
         </p:txBody>
@@ -12276,6 +12498,117 @@
         </p:nvSpPr>
         <p:spPr>
           <a:xfrm>
+            <a:off x="10436047" y="393192"/>
+            <a:ext cx="1152144" cy="530352"/>
+          </a:xfrm>
+          <a:prstGeom prst="roundRect">
+            <a:avLst>
+              <a:gd name="adj" fmla="val 18000"/>
+            </a:avLst>
+          </a:prstGeom>
+          <a:effectLst/>
+          <a:solidFill>
+            <a:srgbClr val="FFFFFF">
+              <a:alpha val="92000"/>
+            </a:srgbClr>
+          </a:solidFill>
+          <a:ln w="10160" cap="flat" cmpd="sng" algn="ctr">
+            <a:solidFill>
+              <a:srgbClr val="0A66E0">
+                <a:alpha val="35000"/>
+              </a:srgbClr>
+            </a:solidFill>
+          </a:ln>
+        </p:spPr>
+        <p:style>
+          <a:lnRef idx="1">
+            <a:schemeClr val="accent1"/>
+          </a:lnRef>
+          <a:fillRef idx="3">
+            <a:schemeClr val="accent1"/>
+          </a:fillRef>
+          <a:effectRef idx="2">
+            <a:schemeClr val="accent1"/>
+          </a:effectRef>
+          <a:fontRef idx="minor">
+            <a:schemeClr val="lt1"/>
+          </a:fontRef>
+        </p:style>
+        <p:txBody>
+          <a:bodyPr rtlCol="0" anchor="ctr"/>
+          <a:lstStyle/>
+          <a:p>
+            <a:pPr algn="ctr"/>
+          </a:p>
+        </p:txBody>
+      </p:sp>
+      <p:sp>
+        <p:nvSpPr>
+          <p:cNvPr id="25" name="TextBox 24"/>
+          <p:cNvSpPr txBox="1"/>
+          <p:nvPr/>
+        </p:nvSpPr>
+        <p:spPr>
+          <a:xfrm>
+            <a:off x="10545775" y="443484"/>
+            <a:ext cx="932688" cy="109728"/>
+          </a:xfrm>
+          <a:prstGeom prst="rect">
+            <a:avLst/>
+          </a:prstGeom>
+          <a:noFill/>
+        </p:spPr>
+        <p:txBody>
+          <a:bodyPr wrap="square" anchor="t" lIns="0" rIns="0" tIns="0" bIns="0">
+            <a:spAutoFit/>
+          </a:bodyPr>
+          <a:lstStyle/>
+          <a:p>
+            <a:pPr algn="ctr"/>
+            <a:r>
+              <a:rPr sz="620" b="1" i="0" spc="80">
+                <a:solidFill>
+                  <a:srgbClr val="8A93B4"/>
+                </a:solidFill>
+                <a:latin typeface="Liberation Sans"/>
+              </a:rPr>
+              <a:t>SUY NGHĨ</a:t>
+            </a:r>
+          </a:p>
+        </p:txBody>
+      </p:sp>
+      <p:pic>
+        <p:nvPicPr>
+          <p:cNvPr id="26" name="Picture 25" descr="suy-nghi-30s.gif"/>
+          <p:cNvPicPr>
+            <a:picLocks noChangeAspect="1"/>
+          </p:cNvPicPr>
+          <p:nvPr/>
+        </p:nvPicPr>
+        <p:blipFill>
+          <a:blip r:embed="rId3"/>
+          <a:stretch>
+            <a:fillRect/>
+          </a:stretch>
+        </p:blipFill>
+        <p:spPr>
+          <a:xfrm>
+            <a:off x="10573207" y="576072"/>
+            <a:ext cx="877824" cy="274320"/>
+          </a:xfrm>
+          <a:prstGeom prst="rect">
+            <a:avLst/>
+          </a:prstGeom>
+        </p:spPr>
+      </p:pic>
+      <p:sp>
+        <p:nvSpPr>
+          <p:cNvPr id="27" name="Rounded Rectangle 26"/>
+          <p:cNvSpPr/>
+          <p:nvPr/>
+        </p:nvSpPr>
+        <p:spPr>
+          <a:xfrm>
             <a:off x="603504" y="1572768"/>
             <a:ext cx="10984687" cy="1335024"/>
           </a:xfrm>
@@ -12322,7 +12655,7 @@
       </p:sp>
       <p:pic>
         <p:nvPicPr>
-          <p:cNvPr id="25" name="Picture 24" descr="person-badge-plus.png"/>
+          <p:cNvPr id="28" name="Picture 27" descr="person-badge-plus.png"/>
           <p:cNvPicPr>
             <a:picLocks noChangeAspect="1"/>
           </p:cNvPicPr>
@@ -12346,7 +12679,7 @@
       </p:pic>
       <p:sp>
         <p:nvSpPr>
-          <p:cNvPr id="26" name="TextBox 25"/>
+          <p:cNvPr id="29" name="TextBox 28"/>
           <p:cNvSpPr txBox="1"/>
           <p:nvPr/>
         </p:nvSpPr>
@@ -12387,14 +12720,14 @@
                 </a:solidFill>
                 <a:latin typeface="Liberation Sans"/>
               </a:rPr>
-              <a:t>Có bạn mới chuyển đến lớp em. Bạn còn nhút nhát, ít nói, ngại tham gia các hoạt động chung cùng các bạn.</a:t>
+              <a:t>Minh là một học sinh mới chuyển đến lớp 7B. Tuy nhiên, Minh là người nhút nhát nên giờ ra chơi thường ngồi một mình trong lớp không chơi cùng các bạn.</a:t>
             </a:r>
           </a:p>
         </p:txBody>
       </p:sp>
       <p:sp>
         <p:nvSpPr>
-          <p:cNvPr id="27" name="Rounded Rectangle 26"/>
+          <p:cNvPr id="30" name="Rounded Rectangle 29"/>
           <p:cNvSpPr/>
           <p:nvPr/>
         </p:nvSpPr>
@@ -12446,7 +12779,7 @@
       </p:sp>
       <p:sp>
         <p:nvSpPr>
-          <p:cNvPr id="28" name="TextBox 27"/>
+          <p:cNvPr id="31" name="TextBox 30"/>
           <p:cNvSpPr txBox="1"/>
           <p:nvPr/>
         </p:nvSpPr>
@@ -12481,7 +12814,7 @@
       </p:sp>
       <p:sp>
         <p:nvSpPr>
-          <p:cNvPr id="29" name="Oval 28"/>
+          <p:cNvPr id="32" name="Oval 31"/>
           <p:cNvSpPr/>
           <p:nvPr/>
         </p:nvSpPr>
@@ -12546,7 +12879,7 @@
       </p:sp>
       <p:sp>
         <p:nvSpPr>
-          <p:cNvPr id="30" name="TextBox 29"/>
+          <p:cNvPr id="33" name="TextBox 32"/>
           <p:cNvSpPr txBox="1"/>
           <p:nvPr/>
         </p:nvSpPr>
@@ -12578,14 +12911,14 @@
                 </a:solidFill>
                 <a:latin typeface="Liberation Sans"/>
               </a:rPr>
-              <a:t>Nếu là người ngồi gần, bạn sẽ nói câu đầu tiên nào để làm quen với bạn mới?</a:t>
+              <a:t>Nếu ngồi gần Minh, bạn sẽ nói câu đầu tiên nào để làm quen với bạn?</a:t>
             </a:r>
           </a:p>
         </p:txBody>
       </p:sp>
       <p:sp>
         <p:nvSpPr>
-          <p:cNvPr id="31" name="Oval 30"/>
+          <p:cNvPr id="34" name="Oval 33"/>
           <p:cNvSpPr/>
           <p:nvPr/>
         </p:nvSpPr>
@@ -12650,7 +12983,7 @@
       </p:sp>
       <p:sp>
         <p:nvSpPr>
-          <p:cNvPr id="32" name="TextBox 31"/>
+          <p:cNvPr id="35" name="TextBox 34"/>
           <p:cNvSpPr txBox="1"/>
           <p:nvPr/>
         </p:nvSpPr>
@@ -12682,14 +13015,14 @@
                 </a:solidFill>
                 <a:latin typeface="Liberation Sans"/>
               </a:rPr>
-              <a:t>Bạn có thể giúp bạn mới bắt nhịp việc học và hoạt động chung ra sao?</a:t>
+              <a:t>Bạn có thể giúp Minh bắt nhịp việc học và hoạt động chung ra sao?</a:t>
             </a:r>
           </a:p>
         </p:txBody>
       </p:sp>
       <p:sp>
         <p:nvSpPr>
-          <p:cNvPr id="33" name="Oval 32"/>
+          <p:cNvPr id="36" name="Oval 35"/>
           <p:cNvSpPr/>
           <p:nvPr/>
         </p:nvSpPr>
@@ -12754,7 +13087,7 @@
       </p:sp>
       <p:sp>
         <p:nvSpPr>
-          <p:cNvPr id="34" name="TextBox 33"/>
+          <p:cNvPr id="37" name="TextBox 36"/>
           <p:cNvSpPr txBox="1"/>
           <p:nvPr/>
         </p:nvSpPr>
@@ -12786,14 +13119,14 @@
                 </a:solidFill>
                 <a:latin typeface="Liberation Sans"/>
               </a:rPr>
-              <a:t>Lớp mình cần tránh những điều gì để bạn không thấy lạc lõng hay bị trêu chọc?</a:t>
+              <a:t>Lớp mình cần tránh những điều gì để Minh không thấy lạc lõng hay bị trêu chọc?</a:t>
             </a:r>
           </a:p>
         </p:txBody>
       </p:sp>
       <p:sp>
         <p:nvSpPr>
-          <p:cNvPr id="35" name="Rounded Rectangle 34"/>
+          <p:cNvPr id="38" name="Rounded Rectangle 37"/>
           <p:cNvSpPr/>
           <p:nvPr/>
         </p:nvSpPr>
@@ -12845,14 +13178,14 @@
       </p:sp>
       <p:pic>
         <p:nvPicPr>
-          <p:cNvPr id="36" name="Picture 35" descr="bubble-pair-fill.png"/>
+          <p:cNvPr id="39" name="Picture 38" descr="bubble-pair-fill.png"/>
           <p:cNvPicPr>
             <a:picLocks noChangeAspect="1"/>
           </p:cNvPicPr>
           <p:nvPr/>
         </p:nvPicPr>
         <p:blipFill>
-          <a:blip r:embed="rId3"/>
+          <a:blip r:embed="rId4"/>
           <a:stretch>
             <a:fillRect/>
           </a:stretch>
@@ -12869,7 +13202,7 @@
       </p:pic>
       <p:sp>
         <p:nvSpPr>
-          <p:cNvPr id="37" name="TextBox 36"/>
+          <p:cNvPr id="40" name="TextBox 39"/>
           <p:cNvSpPr txBox="1"/>
           <p:nvPr/>
         </p:nvSpPr>
@@ -12924,7 +13257,7 @@
       </p:sp>
       <p:sp>
         <p:nvSpPr>
-          <p:cNvPr id="38" name="Rounded Rectangle 37"/>
+          <p:cNvPr id="41" name="Rounded Rectangle 40"/>
           <p:cNvSpPr/>
           <p:nvPr/>
         </p:nvSpPr>
@@ -12976,14 +13309,14 @@
       </p:sp>
       <p:pic>
         <p:nvPicPr>
-          <p:cNvPr id="39" name="Picture 38" descr="bolt-fill.png"/>
+          <p:cNvPr id="42" name="Picture 41" descr="bolt-fill.png"/>
           <p:cNvPicPr>
             <a:picLocks noChangeAspect="1"/>
           </p:cNvPicPr>
           <p:nvPr/>
         </p:nvPicPr>
         <p:blipFill>
-          <a:blip r:embed="rId4"/>
+          <a:blip r:embed="rId5"/>
           <a:stretch>
             <a:fillRect/>
           </a:stretch>
@@ -13000,7 +13333,7 @@
       </p:pic>
       <p:sp>
         <p:nvSpPr>
-          <p:cNvPr id="40" name="TextBox 39"/>
+          <p:cNvPr id="43" name="TextBox 42"/>
           <p:cNvSpPr txBox="1"/>
           <p:nvPr/>
         </p:nvSpPr>
@@ -13051,7 +13384,7 @@
                 </a:solidFill>
                 <a:latin typeface="Liberation Sans"/>
               </a:rPr>
-              <a:t>Chủ động chào hỏi, giúp từ việc nhỏ và để bạn tham gia theo nhịp của mình.</a:t>
+              <a:t>Chủ động chào hỏi, giúp từ việc nhỏ và để Minh tham gia theo nhịp của bạn.</a:t>
             </a:r>
           </a:p>
           <a:p>

</xml_diff>

<commit_message>
Thay đồng hồ GIF bằng video bấm chạy và nút dừng reset
Co-authored-by: arena-agent <297053741+arena-agent@users.noreply.github.com>
</commit_message>
<xml_diff>
--- a/Phát triển mối quan hệ hòa đồng, hợp tác - HĐTN lớp 7 (học sinh thuyết trình).pptx
+++ b/Phát triển mối quan hệ hòa đồng, hợp tác - HĐTN lớp 7 (học sinh thuyết trình).pptx
@@ -8546,8 +8546,8 @@
         </p:nvSpPr>
         <p:spPr>
           <a:xfrm>
-            <a:off x="10436047" y="393192"/>
-            <a:ext cx="1152144" cy="530352"/>
+            <a:off x="9814255" y="329184"/>
+            <a:ext cx="1773936" cy="1033271"/>
           </a:xfrm>
           <a:prstGeom prst="roundRect">
             <a:avLst>
@@ -8557,13 +8557,13 @@
           <a:effectLst/>
           <a:solidFill>
             <a:srgbClr val="FFFFFF">
-              <a:alpha val="92000"/>
+              <a:alpha val="94000"/>
             </a:srgbClr>
           </a:solidFill>
-          <a:ln w="10160" cap="flat" cmpd="sng" algn="ctr">
+          <a:ln w="11430" cap="flat" cmpd="sng" algn="ctr">
             <a:solidFill>
               <a:srgbClr val="0A66E0">
-                <a:alpha val="35000"/>
+                <a:alpha val="48000"/>
               </a:srgbClr>
             </a:solidFill>
           </a:ln>
@@ -8598,8 +8598,8 @@
         </p:nvSpPr>
         <p:spPr>
           <a:xfrm>
-            <a:off x="10545775" y="443484"/>
-            <a:ext cx="932688" cy="109728"/>
+            <a:off x="9923983" y="379476"/>
+            <a:ext cx="1554480" cy="118872"/>
           </a:xfrm>
           <a:prstGeom prst="rect">
             <a:avLst/>
@@ -8614,35 +8614,44 @@
           <a:p>
             <a:pPr algn="ctr"/>
             <a:r>
-              <a:rPr sz="620" b="1" i="0" spc="80">
+              <a:rPr sz="620" b="1" i="0" spc="50">
                 <a:solidFill>
                   <a:srgbClr val="8A93B4"/>
                 </a:solidFill>
                 <a:latin typeface="Liberation Sans"/>
               </a:rPr>
-              <a:t>SUY NGHĨ</a:t>
+              <a:t>BẤM 00:30 ĐỂ BẮT ĐẦU</a:t>
             </a:r>
           </a:p>
         </p:txBody>
       </p:sp>
       <p:pic>
         <p:nvPicPr>
-          <p:cNvPr id="26" name="Picture 25" descr="suy-nghi-30s.gif"/>
+          <p:cNvPr id="26" name="suy-nghi-30s.mp4">
+            <a:hlinkClick r:id="" action="ppaction://media"/>
+          </p:cNvPr>
           <p:cNvPicPr>
             <a:picLocks noChangeAspect="1"/>
           </p:cNvPicPr>
-          <p:nvPr/>
+          <p:nvPr>
+            <a:videoFile r:link="rId4"/>
+            <p:extLst>
+              <p:ext uri="{DAA4B4D4-6D71-4841-9C94-3DE7FCFB9230}">
+                <p14:media xmlns:p14="http://schemas.microsoft.com/office/powerpoint/2010/main" r:embed="rId3"/>
+              </p:ext>
+            </p:extLst>
+          </p:nvPr>
         </p:nvPicPr>
         <p:blipFill>
-          <a:blip r:embed="rId3"/>
+          <a:blip r:embed="rId5"/>
           <a:stretch>
             <a:fillRect/>
           </a:stretch>
         </p:blipFill>
         <p:spPr>
           <a:xfrm>
-            <a:off x="10573207" y="576072"/>
-            <a:ext cx="877824" cy="274320"/>
+            <a:off x="9960559" y="530352"/>
+            <a:ext cx="1481328" cy="457200"/>
           </a:xfrm>
           <a:prstGeom prst="rect">
             <a:avLst/>
@@ -8651,7 +8660,70 @@
       </p:pic>
       <p:sp>
         <p:nvSpPr>
-          <p:cNvPr id="27" name="Rounded Rectangle 26"/>
+          <p:cNvPr id="27" name="Rounded Rectangle 26">
+            <a:hlinkClick action="ppaction://hlinksldjump" r:id="rId6"/>
+          </p:cNvPr>
+          <p:cNvSpPr/>
+          <p:nvPr/>
+        </p:nvSpPr>
+        <p:spPr>
+          <a:xfrm>
+            <a:off x="9960559" y="1051560"/>
+            <a:ext cx="1481328" cy="228600"/>
+          </a:xfrm>
+          <a:prstGeom prst="roundRect">
+            <a:avLst>
+              <a:gd name="adj" fmla="val 12000"/>
+            </a:avLst>
+          </a:prstGeom>
+          <a:effectLst/>
+          <a:solidFill>
+            <a:srgbClr val="DE1F8B">
+              <a:alpha val="14000"/>
+            </a:srgbClr>
+          </a:solidFill>
+          <a:ln w="8890" cap="flat" cmpd="sng" algn="ctr">
+            <a:solidFill>
+              <a:srgbClr val="DE1F8B">
+                <a:alpha val="46000"/>
+              </a:srgbClr>
+            </a:solidFill>
+          </a:ln>
+        </p:spPr>
+        <p:style>
+          <a:lnRef idx="1">
+            <a:schemeClr val="accent1"/>
+          </a:lnRef>
+          <a:fillRef idx="3">
+            <a:schemeClr val="accent1"/>
+          </a:fillRef>
+          <a:effectRef idx="2">
+            <a:schemeClr val="accent1"/>
+          </a:effectRef>
+          <a:fontRef idx="minor">
+            <a:schemeClr val="lt1"/>
+          </a:fontRef>
+        </p:style>
+        <p:txBody>
+          <a:bodyPr rtlCol="0" anchor="ctr" lIns="0" rIns="0" tIns="0" bIns="0"/>
+          <a:lstStyle/>
+          <a:p>
+            <a:pPr algn="ctr"/>
+            <a:r>
+              <a:rPr sz="750" b="1" i="0" spc="30">
+                <a:solidFill>
+                  <a:srgbClr val="DE1F8B"/>
+                </a:solidFill>
+                <a:latin typeface="Liberation Sans"/>
+              </a:rPr>
+              <a:t>DỪNG · RESET</a:t>
+            </a:r>
+          </a:p>
+        </p:txBody>
+      </p:sp>
+      <p:sp>
+        <p:nvSpPr>
+          <p:cNvPr id="28" name="Rounded Rectangle 27"/>
           <p:cNvSpPr/>
           <p:nvPr/>
         </p:nvSpPr>
@@ -8703,7 +8775,7 @@
       </p:sp>
       <p:pic>
         <p:nvPicPr>
-          <p:cNvPr id="28" name="Picture 27" descr="drop-triangle-fill.png"/>
+          <p:cNvPr id="29" name="Picture 28" descr="drop-triangle-fill.png"/>
           <p:cNvPicPr>
             <a:picLocks noChangeAspect="1"/>
           </p:cNvPicPr>
@@ -8727,7 +8799,7 @@
       </p:pic>
       <p:sp>
         <p:nvSpPr>
-          <p:cNvPr id="29" name="TextBox 28"/>
+          <p:cNvPr id="30" name="TextBox 29"/>
           <p:cNvSpPr txBox="1"/>
           <p:nvPr/>
         </p:nvSpPr>
@@ -8775,7 +8847,7 @@
       </p:sp>
       <p:sp>
         <p:nvSpPr>
-          <p:cNvPr id="30" name="Rounded Rectangle 29"/>
+          <p:cNvPr id="31" name="Rounded Rectangle 30"/>
           <p:cNvSpPr/>
           <p:nvPr/>
         </p:nvSpPr>
@@ -8827,7 +8899,7 @@
       </p:sp>
       <p:sp>
         <p:nvSpPr>
-          <p:cNvPr id="31" name="TextBox 30"/>
+          <p:cNvPr id="32" name="TextBox 31"/>
           <p:cNvSpPr txBox="1"/>
           <p:nvPr/>
         </p:nvSpPr>
@@ -8862,7 +8934,7 @@
       </p:sp>
       <p:sp>
         <p:nvSpPr>
-          <p:cNvPr id="32" name="Oval 31"/>
+          <p:cNvPr id="33" name="Oval 32"/>
           <p:cNvSpPr/>
           <p:nvPr/>
         </p:nvSpPr>
@@ -8927,7 +8999,7 @@
       </p:sp>
       <p:sp>
         <p:nvSpPr>
-          <p:cNvPr id="33" name="TextBox 32"/>
+          <p:cNvPr id="34" name="TextBox 33"/>
           <p:cNvSpPr txBox="1"/>
           <p:nvPr/>
         </p:nvSpPr>
@@ -8966,7 +9038,7 @@
       </p:sp>
       <p:sp>
         <p:nvSpPr>
-          <p:cNvPr id="34" name="Oval 33"/>
+          <p:cNvPr id="35" name="Oval 34"/>
           <p:cNvSpPr/>
           <p:nvPr/>
         </p:nvSpPr>
@@ -9031,7 +9103,7 @@
       </p:sp>
       <p:sp>
         <p:nvSpPr>
-          <p:cNvPr id="35" name="TextBox 34"/>
+          <p:cNvPr id="36" name="TextBox 35"/>
           <p:cNvSpPr txBox="1"/>
           <p:nvPr/>
         </p:nvSpPr>
@@ -9070,7 +9142,7 @@
       </p:sp>
       <p:sp>
         <p:nvSpPr>
-          <p:cNvPr id="36" name="Oval 35"/>
+          <p:cNvPr id="37" name="Oval 36"/>
           <p:cNvSpPr/>
           <p:nvPr/>
         </p:nvSpPr>
@@ -9135,7 +9207,7 @@
       </p:sp>
       <p:sp>
         <p:nvSpPr>
-          <p:cNvPr id="37" name="TextBox 36"/>
+          <p:cNvPr id="38" name="TextBox 37"/>
           <p:cNvSpPr txBox="1"/>
           <p:nvPr/>
         </p:nvSpPr>
@@ -9174,7 +9246,7 @@
       </p:sp>
       <p:sp>
         <p:nvSpPr>
-          <p:cNvPr id="38" name="Rounded Rectangle 37"/>
+          <p:cNvPr id="39" name="Rounded Rectangle 38"/>
           <p:cNvSpPr/>
           <p:nvPr/>
         </p:nvSpPr>
@@ -9226,14 +9298,14 @@
       </p:sp>
       <p:pic>
         <p:nvPicPr>
-          <p:cNvPr id="39" name="Picture 38" descr="bubble-pair-fill.png"/>
+          <p:cNvPr id="40" name="Picture 39" descr="bubble-pair-fill.png"/>
           <p:cNvPicPr>
             <a:picLocks noChangeAspect="1"/>
           </p:cNvPicPr>
           <p:nvPr/>
         </p:nvPicPr>
         <p:blipFill>
-          <a:blip r:embed="rId4"/>
+          <a:blip r:embed="rId7"/>
           <a:stretch>
             <a:fillRect/>
           </a:stretch>
@@ -9250,7 +9322,7 @@
       </p:pic>
       <p:sp>
         <p:nvSpPr>
-          <p:cNvPr id="40" name="TextBox 39"/>
+          <p:cNvPr id="41" name="TextBox 40"/>
           <p:cNvSpPr txBox="1"/>
           <p:nvPr/>
         </p:nvSpPr>
@@ -9305,7 +9377,7 @@
       </p:sp>
       <p:sp>
         <p:nvSpPr>
-          <p:cNvPr id="41" name="Rounded Rectangle 40"/>
+          <p:cNvPr id="42" name="Rounded Rectangle 41"/>
           <p:cNvSpPr/>
           <p:nvPr/>
         </p:nvSpPr>
@@ -9357,14 +9429,14 @@
       </p:sp>
       <p:pic>
         <p:nvPicPr>
-          <p:cNvPr id="42" name="Picture 41" descr="bolt-fill.png"/>
+          <p:cNvPr id="43" name="Picture 42" descr="bolt-fill.png"/>
           <p:cNvPicPr>
             <a:picLocks noChangeAspect="1"/>
           </p:cNvPicPr>
           <p:nvPr/>
         </p:nvPicPr>
         <p:blipFill>
-          <a:blip r:embed="rId5"/>
+          <a:blip r:embed="rId8"/>
           <a:stretch>
             <a:fillRect/>
           </a:stretch>
@@ -9381,7 +9453,7 @@
       </p:pic>
       <p:sp>
         <p:nvSpPr>
-          <p:cNvPr id="43" name="TextBox 42"/>
+          <p:cNvPr id="44" name="TextBox 43"/>
           <p:cNvSpPr txBox="1"/>
           <p:nvPr/>
         </p:nvSpPr>
@@ -9461,6 +9533,28 @@
   <p:transition spd="med">
     <p:fade/>
   </p:transition>
+  <p:timing>
+    <p:tnLst>
+      <p:par>
+        <p:cTn id="1" dur="indefinite" restart="never" nodeType="tmRoot">
+          <p:childTnLst>
+            <p:video>
+              <p:cMediaNode vol="80000">
+                <p:cTn id="2" fill="hold" display="0">
+                  <p:stCondLst>
+                    <p:cond delay="indefinite"/>
+                  </p:stCondLst>
+                </p:cTn>
+                <p:tgtEl>
+                  <p:spTgt spid="26"/>
+                </p:tgtEl>
+              </p:cMediaNode>
+            </p:video>
+          </p:childTnLst>
+        </p:cTn>
+      </p:par>
+    </p:tnLst>
+  </p:timing>
 </p:sld>
 </file>
 
@@ -10522,8 +10616,8 @@
         </p:nvSpPr>
         <p:spPr>
           <a:xfrm>
-            <a:off x="10436047" y="393192"/>
-            <a:ext cx="1152144" cy="530352"/>
+            <a:off x="9814255" y="329184"/>
+            <a:ext cx="1773936" cy="1033271"/>
           </a:xfrm>
           <a:prstGeom prst="roundRect">
             <a:avLst>
@@ -10533,13 +10627,13 @@
           <a:effectLst/>
           <a:solidFill>
             <a:srgbClr val="FFFFFF">
-              <a:alpha val="92000"/>
+              <a:alpha val="94000"/>
             </a:srgbClr>
           </a:solidFill>
-          <a:ln w="10160" cap="flat" cmpd="sng" algn="ctr">
+          <a:ln w="11430" cap="flat" cmpd="sng" algn="ctr">
             <a:solidFill>
               <a:srgbClr val="0A66E0">
-                <a:alpha val="35000"/>
+                <a:alpha val="48000"/>
               </a:srgbClr>
             </a:solidFill>
           </a:ln>
@@ -10574,8 +10668,8 @@
         </p:nvSpPr>
         <p:spPr>
           <a:xfrm>
-            <a:off x="10545775" y="443484"/>
-            <a:ext cx="932688" cy="109728"/>
+            <a:off x="9923983" y="379476"/>
+            <a:ext cx="1554480" cy="118872"/>
           </a:xfrm>
           <a:prstGeom prst="rect">
             <a:avLst/>
@@ -10590,35 +10684,44 @@
           <a:p>
             <a:pPr algn="ctr"/>
             <a:r>
-              <a:rPr sz="620" b="1" i="0" spc="80">
+              <a:rPr sz="620" b="1" i="0" spc="50">
                 <a:solidFill>
                   <a:srgbClr val="8A93B4"/>
                 </a:solidFill>
                 <a:latin typeface="Liberation Sans"/>
               </a:rPr>
-              <a:t>SUY NGHĨ</a:t>
+              <a:t>BẤM 00:30 ĐỂ BẮT ĐẦU</a:t>
             </a:r>
           </a:p>
         </p:txBody>
       </p:sp>
       <p:pic>
         <p:nvPicPr>
-          <p:cNvPr id="26" name="Picture 25" descr="suy-nghi-30s.gif"/>
+          <p:cNvPr id="26" name="suy-nghi-30s.mp4">
+            <a:hlinkClick r:id="" action="ppaction://media"/>
+          </p:cNvPr>
           <p:cNvPicPr>
             <a:picLocks noChangeAspect="1"/>
           </p:cNvPicPr>
-          <p:nvPr/>
+          <p:nvPr>
+            <a:videoFile r:link="rId4"/>
+            <p:extLst>
+              <p:ext uri="{DAA4B4D4-6D71-4841-9C94-3DE7FCFB9230}">
+                <p14:media xmlns:p14="http://schemas.microsoft.com/office/powerpoint/2010/main" r:embed="rId3"/>
+              </p:ext>
+            </p:extLst>
+          </p:nvPr>
         </p:nvPicPr>
         <p:blipFill>
-          <a:blip r:embed="rId3"/>
+          <a:blip r:embed="rId5"/>
           <a:stretch>
             <a:fillRect/>
           </a:stretch>
         </p:blipFill>
         <p:spPr>
           <a:xfrm>
-            <a:off x="10573207" y="576072"/>
-            <a:ext cx="877824" cy="274320"/>
+            <a:off x="9960559" y="530352"/>
+            <a:ext cx="1481328" cy="457200"/>
           </a:xfrm>
           <a:prstGeom prst="rect">
             <a:avLst/>
@@ -10627,7 +10730,70 @@
       </p:pic>
       <p:sp>
         <p:nvSpPr>
-          <p:cNvPr id="27" name="Rounded Rectangle 26"/>
+          <p:cNvPr id="27" name="Rounded Rectangle 26">
+            <a:hlinkClick action="ppaction://hlinksldjump" r:id="rId6"/>
+          </p:cNvPr>
+          <p:cNvSpPr/>
+          <p:nvPr/>
+        </p:nvSpPr>
+        <p:spPr>
+          <a:xfrm>
+            <a:off x="9960559" y="1051560"/>
+            <a:ext cx="1481328" cy="228600"/>
+          </a:xfrm>
+          <a:prstGeom prst="roundRect">
+            <a:avLst>
+              <a:gd name="adj" fmla="val 12000"/>
+            </a:avLst>
+          </a:prstGeom>
+          <a:effectLst/>
+          <a:solidFill>
+            <a:srgbClr val="DE1F8B">
+              <a:alpha val="14000"/>
+            </a:srgbClr>
+          </a:solidFill>
+          <a:ln w="8890" cap="flat" cmpd="sng" algn="ctr">
+            <a:solidFill>
+              <a:srgbClr val="DE1F8B">
+                <a:alpha val="46000"/>
+              </a:srgbClr>
+            </a:solidFill>
+          </a:ln>
+        </p:spPr>
+        <p:style>
+          <a:lnRef idx="1">
+            <a:schemeClr val="accent1"/>
+          </a:lnRef>
+          <a:fillRef idx="3">
+            <a:schemeClr val="accent1"/>
+          </a:fillRef>
+          <a:effectRef idx="2">
+            <a:schemeClr val="accent1"/>
+          </a:effectRef>
+          <a:fontRef idx="minor">
+            <a:schemeClr val="lt1"/>
+          </a:fontRef>
+        </p:style>
+        <p:txBody>
+          <a:bodyPr rtlCol="0" anchor="ctr" lIns="0" rIns="0" tIns="0" bIns="0"/>
+          <a:lstStyle/>
+          <a:p>
+            <a:pPr algn="ctr"/>
+            <a:r>
+              <a:rPr sz="750" b="1" i="0" spc="30">
+                <a:solidFill>
+                  <a:srgbClr val="DE1F8B"/>
+                </a:solidFill>
+                <a:latin typeface="Liberation Sans"/>
+              </a:rPr>
+              <a:t>DỪNG · RESET</a:t>
+            </a:r>
+          </a:p>
+        </p:txBody>
+      </p:sp>
+      <p:sp>
+        <p:nvSpPr>
+          <p:cNvPr id="28" name="Rounded Rectangle 27"/>
           <p:cNvSpPr/>
           <p:nvPr/>
         </p:nvSpPr>
@@ -10679,7 +10845,7 @@
       </p:sp>
       <p:pic>
         <p:nvPicPr>
-          <p:cNvPr id="28" name="Picture 27" descr="waveform.png"/>
+          <p:cNvPr id="29" name="Picture 28" descr="waveform.png"/>
           <p:cNvPicPr>
             <a:picLocks noChangeAspect="1"/>
           </p:cNvPicPr>
@@ -10703,7 +10869,7 @@
       </p:pic>
       <p:sp>
         <p:nvSpPr>
-          <p:cNvPr id="29" name="TextBox 28"/>
+          <p:cNvPr id="30" name="TextBox 29"/>
           <p:cNvSpPr txBox="1"/>
           <p:nvPr/>
         </p:nvSpPr>
@@ -10751,7 +10917,7 @@
       </p:sp>
       <p:sp>
         <p:nvSpPr>
-          <p:cNvPr id="30" name="Rounded Rectangle 29"/>
+          <p:cNvPr id="31" name="Rounded Rectangle 30"/>
           <p:cNvSpPr/>
           <p:nvPr/>
         </p:nvSpPr>
@@ -10803,7 +10969,7 @@
       </p:sp>
       <p:sp>
         <p:nvSpPr>
-          <p:cNvPr id="31" name="TextBox 30"/>
+          <p:cNvPr id="32" name="TextBox 31"/>
           <p:cNvSpPr txBox="1"/>
           <p:nvPr/>
         </p:nvSpPr>
@@ -10838,7 +11004,7 @@
       </p:sp>
       <p:sp>
         <p:nvSpPr>
-          <p:cNvPr id="32" name="Oval 31"/>
+          <p:cNvPr id="33" name="Oval 32"/>
           <p:cNvSpPr/>
           <p:nvPr/>
         </p:nvSpPr>
@@ -10903,7 +11069,7 @@
       </p:sp>
       <p:sp>
         <p:nvSpPr>
-          <p:cNvPr id="33" name="TextBox 32"/>
+          <p:cNvPr id="34" name="TextBox 33"/>
           <p:cNvSpPr txBox="1"/>
           <p:nvPr/>
         </p:nvSpPr>
@@ -10942,7 +11108,7 @@
       </p:sp>
       <p:sp>
         <p:nvSpPr>
-          <p:cNvPr id="34" name="Oval 33"/>
+          <p:cNvPr id="35" name="Oval 34"/>
           <p:cNvSpPr/>
           <p:nvPr/>
         </p:nvSpPr>
@@ -11007,7 +11173,7 @@
       </p:sp>
       <p:sp>
         <p:nvSpPr>
-          <p:cNvPr id="35" name="TextBox 34"/>
+          <p:cNvPr id="36" name="TextBox 35"/>
           <p:cNvSpPr txBox="1"/>
           <p:nvPr/>
         </p:nvSpPr>
@@ -11046,7 +11212,7 @@
       </p:sp>
       <p:sp>
         <p:nvSpPr>
-          <p:cNvPr id="36" name="Oval 35"/>
+          <p:cNvPr id="37" name="Oval 36"/>
           <p:cNvSpPr/>
           <p:nvPr/>
         </p:nvSpPr>
@@ -11111,7 +11277,7 @@
       </p:sp>
       <p:sp>
         <p:nvSpPr>
-          <p:cNvPr id="37" name="TextBox 36"/>
+          <p:cNvPr id="38" name="TextBox 37"/>
           <p:cNvSpPr txBox="1"/>
           <p:nvPr/>
         </p:nvSpPr>
@@ -11150,7 +11316,7 @@
       </p:sp>
       <p:sp>
         <p:nvSpPr>
-          <p:cNvPr id="38" name="Rounded Rectangle 37"/>
+          <p:cNvPr id="39" name="Rounded Rectangle 38"/>
           <p:cNvSpPr/>
           <p:nvPr/>
         </p:nvSpPr>
@@ -11202,14 +11368,14 @@
       </p:sp>
       <p:pic>
         <p:nvPicPr>
-          <p:cNvPr id="39" name="Picture 38" descr="bubble-pair-fill.png"/>
+          <p:cNvPr id="40" name="Picture 39" descr="bubble-pair-fill.png"/>
           <p:cNvPicPr>
             <a:picLocks noChangeAspect="1"/>
           </p:cNvPicPr>
           <p:nvPr/>
         </p:nvPicPr>
         <p:blipFill>
-          <a:blip r:embed="rId4"/>
+          <a:blip r:embed="rId7"/>
           <a:stretch>
             <a:fillRect/>
           </a:stretch>
@@ -11226,7 +11392,7 @@
       </p:pic>
       <p:sp>
         <p:nvSpPr>
-          <p:cNvPr id="40" name="TextBox 39"/>
+          <p:cNvPr id="41" name="TextBox 40"/>
           <p:cNvSpPr txBox="1"/>
           <p:nvPr/>
         </p:nvSpPr>
@@ -11281,7 +11447,7 @@
       </p:sp>
       <p:sp>
         <p:nvSpPr>
-          <p:cNvPr id="41" name="Rounded Rectangle 40"/>
+          <p:cNvPr id="42" name="Rounded Rectangle 41"/>
           <p:cNvSpPr/>
           <p:nvPr/>
         </p:nvSpPr>
@@ -11333,14 +11499,14 @@
       </p:sp>
       <p:pic>
         <p:nvPicPr>
-          <p:cNvPr id="42" name="Picture 41" descr="bolt-fill.png"/>
+          <p:cNvPr id="43" name="Picture 42" descr="bolt-fill.png"/>
           <p:cNvPicPr>
             <a:picLocks noChangeAspect="1"/>
           </p:cNvPicPr>
           <p:nvPr/>
         </p:nvPicPr>
         <p:blipFill>
-          <a:blip r:embed="rId5"/>
+          <a:blip r:embed="rId8"/>
           <a:stretch>
             <a:fillRect/>
           </a:stretch>
@@ -11357,7 +11523,7 @@
       </p:pic>
       <p:sp>
         <p:nvSpPr>
-          <p:cNvPr id="43" name="TextBox 42"/>
+          <p:cNvPr id="44" name="TextBox 43"/>
           <p:cNvSpPr txBox="1"/>
           <p:nvPr/>
         </p:nvSpPr>
@@ -11437,6 +11603,28 @@
   <p:transition spd="med">
     <p:fade/>
   </p:transition>
+  <p:timing>
+    <p:tnLst>
+      <p:par>
+        <p:cTn id="1" dur="indefinite" restart="never" nodeType="tmRoot">
+          <p:childTnLst>
+            <p:video>
+              <p:cMediaNode vol="80000">
+                <p:cTn id="2" fill="hold" display="0">
+                  <p:stCondLst>
+                    <p:cond delay="indefinite"/>
+                  </p:stCondLst>
+                </p:cTn>
+                <p:tgtEl>
+                  <p:spTgt spid="26"/>
+                </p:tgtEl>
+              </p:cMediaNode>
+            </p:video>
+          </p:childTnLst>
+        </p:cTn>
+      </p:par>
+    </p:tnLst>
+  </p:timing>
 </p:sld>
 </file>
 
@@ -12498,8 +12686,8 @@
         </p:nvSpPr>
         <p:spPr>
           <a:xfrm>
-            <a:off x="10436047" y="393192"/>
-            <a:ext cx="1152144" cy="530352"/>
+            <a:off x="9814255" y="329184"/>
+            <a:ext cx="1773936" cy="1033271"/>
           </a:xfrm>
           <a:prstGeom prst="roundRect">
             <a:avLst>
@@ -12509,13 +12697,13 @@
           <a:effectLst/>
           <a:solidFill>
             <a:srgbClr val="FFFFFF">
-              <a:alpha val="92000"/>
+              <a:alpha val="94000"/>
             </a:srgbClr>
           </a:solidFill>
-          <a:ln w="10160" cap="flat" cmpd="sng" algn="ctr">
+          <a:ln w="11430" cap="flat" cmpd="sng" algn="ctr">
             <a:solidFill>
               <a:srgbClr val="0A66E0">
-                <a:alpha val="35000"/>
+                <a:alpha val="48000"/>
               </a:srgbClr>
             </a:solidFill>
           </a:ln>
@@ -12550,8 +12738,8 @@
         </p:nvSpPr>
         <p:spPr>
           <a:xfrm>
-            <a:off x="10545775" y="443484"/>
-            <a:ext cx="932688" cy="109728"/>
+            <a:off x="9923983" y="379476"/>
+            <a:ext cx="1554480" cy="118872"/>
           </a:xfrm>
           <a:prstGeom prst="rect">
             <a:avLst/>
@@ -12566,35 +12754,44 @@
           <a:p>
             <a:pPr algn="ctr"/>
             <a:r>
-              <a:rPr sz="620" b="1" i="0" spc="80">
+              <a:rPr sz="620" b="1" i="0" spc="50">
                 <a:solidFill>
                   <a:srgbClr val="8A93B4"/>
                 </a:solidFill>
                 <a:latin typeface="Liberation Sans"/>
               </a:rPr>
-              <a:t>SUY NGHĨ</a:t>
+              <a:t>BẤM 00:30 ĐỂ BẮT ĐẦU</a:t>
             </a:r>
           </a:p>
         </p:txBody>
       </p:sp>
       <p:pic>
         <p:nvPicPr>
-          <p:cNvPr id="26" name="Picture 25" descr="suy-nghi-30s.gif"/>
+          <p:cNvPr id="26" name="suy-nghi-30s.mp4">
+            <a:hlinkClick r:id="" action="ppaction://media"/>
+          </p:cNvPr>
           <p:cNvPicPr>
             <a:picLocks noChangeAspect="1"/>
           </p:cNvPicPr>
-          <p:nvPr/>
+          <p:nvPr>
+            <a:videoFile r:link="rId4"/>
+            <p:extLst>
+              <p:ext uri="{DAA4B4D4-6D71-4841-9C94-3DE7FCFB9230}">
+                <p14:media xmlns:p14="http://schemas.microsoft.com/office/powerpoint/2010/main" r:embed="rId3"/>
+              </p:ext>
+            </p:extLst>
+          </p:nvPr>
         </p:nvPicPr>
         <p:blipFill>
-          <a:blip r:embed="rId3"/>
+          <a:blip r:embed="rId5"/>
           <a:stretch>
             <a:fillRect/>
           </a:stretch>
         </p:blipFill>
         <p:spPr>
           <a:xfrm>
-            <a:off x="10573207" y="576072"/>
-            <a:ext cx="877824" cy="274320"/>
+            <a:off x="9960559" y="530352"/>
+            <a:ext cx="1481328" cy="457200"/>
           </a:xfrm>
           <a:prstGeom prst="rect">
             <a:avLst/>
@@ -12603,7 +12800,70 @@
       </p:pic>
       <p:sp>
         <p:nvSpPr>
-          <p:cNvPr id="27" name="Rounded Rectangle 26"/>
+          <p:cNvPr id="27" name="Rounded Rectangle 26">
+            <a:hlinkClick action="ppaction://hlinksldjump" r:id="rId6"/>
+          </p:cNvPr>
+          <p:cNvSpPr/>
+          <p:nvPr/>
+        </p:nvSpPr>
+        <p:spPr>
+          <a:xfrm>
+            <a:off x="9960559" y="1051560"/>
+            <a:ext cx="1481328" cy="228600"/>
+          </a:xfrm>
+          <a:prstGeom prst="roundRect">
+            <a:avLst>
+              <a:gd name="adj" fmla="val 12000"/>
+            </a:avLst>
+          </a:prstGeom>
+          <a:effectLst/>
+          <a:solidFill>
+            <a:srgbClr val="DE1F8B">
+              <a:alpha val="14000"/>
+            </a:srgbClr>
+          </a:solidFill>
+          <a:ln w="8890" cap="flat" cmpd="sng" algn="ctr">
+            <a:solidFill>
+              <a:srgbClr val="DE1F8B">
+                <a:alpha val="46000"/>
+              </a:srgbClr>
+            </a:solidFill>
+          </a:ln>
+        </p:spPr>
+        <p:style>
+          <a:lnRef idx="1">
+            <a:schemeClr val="accent1"/>
+          </a:lnRef>
+          <a:fillRef idx="3">
+            <a:schemeClr val="accent1"/>
+          </a:fillRef>
+          <a:effectRef idx="2">
+            <a:schemeClr val="accent1"/>
+          </a:effectRef>
+          <a:fontRef idx="minor">
+            <a:schemeClr val="lt1"/>
+          </a:fontRef>
+        </p:style>
+        <p:txBody>
+          <a:bodyPr rtlCol="0" anchor="ctr" lIns="0" rIns="0" tIns="0" bIns="0"/>
+          <a:lstStyle/>
+          <a:p>
+            <a:pPr algn="ctr"/>
+            <a:r>
+              <a:rPr sz="750" b="1" i="0" spc="30">
+                <a:solidFill>
+                  <a:srgbClr val="DE1F8B"/>
+                </a:solidFill>
+                <a:latin typeface="Liberation Sans"/>
+              </a:rPr>
+              <a:t>DỪNG · RESET</a:t>
+            </a:r>
+          </a:p>
+        </p:txBody>
+      </p:sp>
+      <p:sp>
+        <p:nvSpPr>
+          <p:cNvPr id="28" name="Rounded Rectangle 27"/>
           <p:cNvSpPr/>
           <p:nvPr/>
         </p:nvSpPr>
@@ -12655,7 +12915,7 @@
       </p:sp>
       <p:pic>
         <p:nvPicPr>
-          <p:cNvPr id="28" name="Picture 27" descr="person-badge-plus.png"/>
+          <p:cNvPr id="29" name="Picture 28" descr="person-badge-plus.png"/>
           <p:cNvPicPr>
             <a:picLocks noChangeAspect="1"/>
           </p:cNvPicPr>
@@ -12679,7 +12939,7 @@
       </p:pic>
       <p:sp>
         <p:nvSpPr>
-          <p:cNvPr id="29" name="TextBox 28"/>
+          <p:cNvPr id="30" name="TextBox 29"/>
           <p:cNvSpPr txBox="1"/>
           <p:nvPr/>
         </p:nvSpPr>
@@ -12727,7 +12987,7 @@
       </p:sp>
       <p:sp>
         <p:nvSpPr>
-          <p:cNvPr id="30" name="Rounded Rectangle 29"/>
+          <p:cNvPr id="31" name="Rounded Rectangle 30"/>
           <p:cNvSpPr/>
           <p:nvPr/>
         </p:nvSpPr>
@@ -12779,7 +13039,7 @@
       </p:sp>
       <p:sp>
         <p:nvSpPr>
-          <p:cNvPr id="31" name="TextBox 30"/>
+          <p:cNvPr id="32" name="TextBox 31"/>
           <p:cNvSpPr txBox="1"/>
           <p:nvPr/>
         </p:nvSpPr>
@@ -12814,7 +13074,7 @@
       </p:sp>
       <p:sp>
         <p:nvSpPr>
-          <p:cNvPr id="32" name="Oval 31"/>
+          <p:cNvPr id="33" name="Oval 32"/>
           <p:cNvSpPr/>
           <p:nvPr/>
         </p:nvSpPr>
@@ -12879,7 +13139,7 @@
       </p:sp>
       <p:sp>
         <p:nvSpPr>
-          <p:cNvPr id="33" name="TextBox 32"/>
+          <p:cNvPr id="34" name="TextBox 33"/>
           <p:cNvSpPr txBox="1"/>
           <p:nvPr/>
         </p:nvSpPr>
@@ -12918,7 +13178,7 @@
       </p:sp>
       <p:sp>
         <p:nvSpPr>
-          <p:cNvPr id="34" name="Oval 33"/>
+          <p:cNvPr id="35" name="Oval 34"/>
           <p:cNvSpPr/>
           <p:nvPr/>
         </p:nvSpPr>
@@ -12983,7 +13243,7 @@
       </p:sp>
       <p:sp>
         <p:nvSpPr>
-          <p:cNvPr id="35" name="TextBox 34"/>
+          <p:cNvPr id="36" name="TextBox 35"/>
           <p:cNvSpPr txBox="1"/>
           <p:nvPr/>
         </p:nvSpPr>
@@ -13022,7 +13282,7 @@
       </p:sp>
       <p:sp>
         <p:nvSpPr>
-          <p:cNvPr id="36" name="Oval 35"/>
+          <p:cNvPr id="37" name="Oval 36"/>
           <p:cNvSpPr/>
           <p:nvPr/>
         </p:nvSpPr>
@@ -13087,7 +13347,7 @@
       </p:sp>
       <p:sp>
         <p:nvSpPr>
-          <p:cNvPr id="37" name="TextBox 36"/>
+          <p:cNvPr id="38" name="TextBox 37"/>
           <p:cNvSpPr txBox="1"/>
           <p:nvPr/>
         </p:nvSpPr>
@@ -13126,7 +13386,7 @@
       </p:sp>
       <p:sp>
         <p:nvSpPr>
-          <p:cNvPr id="38" name="Rounded Rectangle 37"/>
+          <p:cNvPr id="39" name="Rounded Rectangle 38"/>
           <p:cNvSpPr/>
           <p:nvPr/>
         </p:nvSpPr>
@@ -13178,14 +13438,14 @@
       </p:sp>
       <p:pic>
         <p:nvPicPr>
-          <p:cNvPr id="39" name="Picture 38" descr="bubble-pair-fill.png"/>
+          <p:cNvPr id="40" name="Picture 39" descr="bubble-pair-fill.png"/>
           <p:cNvPicPr>
             <a:picLocks noChangeAspect="1"/>
           </p:cNvPicPr>
           <p:nvPr/>
         </p:nvPicPr>
         <p:blipFill>
-          <a:blip r:embed="rId4"/>
+          <a:blip r:embed="rId7"/>
           <a:stretch>
             <a:fillRect/>
           </a:stretch>
@@ -13202,7 +13462,7 @@
       </p:pic>
       <p:sp>
         <p:nvSpPr>
-          <p:cNvPr id="40" name="TextBox 39"/>
+          <p:cNvPr id="41" name="TextBox 40"/>
           <p:cNvSpPr txBox="1"/>
           <p:nvPr/>
         </p:nvSpPr>
@@ -13257,7 +13517,7 @@
       </p:sp>
       <p:sp>
         <p:nvSpPr>
-          <p:cNvPr id="41" name="Rounded Rectangle 40"/>
+          <p:cNvPr id="42" name="Rounded Rectangle 41"/>
           <p:cNvSpPr/>
           <p:nvPr/>
         </p:nvSpPr>
@@ -13309,14 +13569,14 @@
       </p:sp>
       <p:pic>
         <p:nvPicPr>
-          <p:cNvPr id="42" name="Picture 41" descr="bolt-fill.png"/>
+          <p:cNvPr id="43" name="Picture 42" descr="bolt-fill.png"/>
           <p:cNvPicPr>
             <a:picLocks noChangeAspect="1"/>
           </p:cNvPicPr>
           <p:nvPr/>
         </p:nvPicPr>
         <p:blipFill>
-          <a:blip r:embed="rId5"/>
+          <a:blip r:embed="rId8"/>
           <a:stretch>
             <a:fillRect/>
           </a:stretch>
@@ -13333,7 +13593,7 @@
       </p:pic>
       <p:sp>
         <p:nvSpPr>
-          <p:cNvPr id="43" name="TextBox 42"/>
+          <p:cNvPr id="44" name="TextBox 43"/>
           <p:cNvSpPr txBox="1"/>
           <p:nvPr/>
         </p:nvSpPr>
@@ -13413,6 +13673,28 @@
   <p:transition spd="med">
     <p:fade/>
   </p:transition>
+  <p:timing>
+    <p:tnLst>
+      <p:par>
+        <p:cTn id="1" dur="indefinite" restart="never" nodeType="tmRoot">
+          <p:childTnLst>
+            <p:video>
+              <p:cMediaNode vol="80000">
+                <p:cTn id="2" fill="hold" display="0">
+                  <p:stCondLst>
+                    <p:cond delay="indefinite"/>
+                  </p:stCondLst>
+                </p:cTn>
+                <p:tgtEl>
+                  <p:spTgt spid="26"/>
+                </p:tgtEl>
+              </p:cMediaNode>
+            </p:video>
+          </p:childTnLst>
+        </p:cTn>
+      </p:par>
+    </p:tnLst>
+  </p:timing>
 </p:sld>
 </file>
 

</xml_diff>